<commit_message>
refactor: unify Basic/Pro IM into single IM, fix grade A without rent roll, simplify NDA
1. Grade bug fix:
   - grade-engine.ts: income/operating posture caps at B grade without structured rent roll
   - data-quality-badge.ts: income A-grade now requires hasFloorLeases

2. Basic/Pro IM unification (12 files):
   - Remove 'Basic IM'/'Pro IM' terminology across all UI components
   - Unified to single 'IM 생성'/'IM 수정' flow
   - deck-sequencer: grade-based (A/B/C) slide count instead of tier-based
   - im-render-policy: grade-based data visibility instead of tier+NDA
   - handler.ts: remove Pro tier gating block

3. NDA simplification:
   - GateRequestsInbox: 'NDA 서명 요청' -> 'IM 열람 승인'
   - Remove Pro IM blur preview from mobile-im-viewer
   - TieredMap: remove 'Pro IM' reference
</commit_message>
<xml_diff>
--- a/docs/test0823/outputs/caseA_dangsan_115b/captures/dangsan_slide.pptx
+++ b/docs/test0823/outputs/caseA_dangsan_115b/captures/dangsan_slide.pptx
@@ -6373,7 +6373,7 @@
                 <a:ea typeface="Pretendard" pitchFamily="34" charset="-122"/>
                 <a:cs typeface="Pretendard" pitchFamily="34" charset="-120"/>
               </a:rPr>
-              <a:t>우량 메디컬/근생 테넌트 직영 만실 운영</a:t>
+              <a:t>물건 접면 도로 및 교통 여건은 현장 실사 확인 사항입니다</a:t>
             </a:r>
             <a:endParaRPr lang="en-US" sz="930" dirty="0"/>
           </a:p>
@@ -6394,7 +6394,7 @@
                 <a:ea typeface="Pretendard" pitchFamily="34" charset="-122"/>
                 <a:cs typeface="Pretendard" pitchFamily="34" charset="-120"/>
               </a:rPr>
-              <a:t>승강기 완비 및 자주식 주차 공간 확보</a:t>
+              <a:t>상세 임대차 계약 내역은 원본 계약서 대조가 필요합니다</a:t>
             </a:r>
             <a:endParaRPr lang="en-US" sz="930" dirty="0"/>
           </a:p>
@@ -6415,7 +6415,7 @@
                 <a:ea typeface="Pretendard" pitchFamily="34" charset="-122"/>
                 <a:cs typeface="Pretendard" pitchFamily="34" charset="-120"/>
               </a:rPr>
-              <a:t>공법상 잔여 용적률 활용 가치 상승 잠재력</a:t>
+              <a:t>건축물 제원 및 용도 현황은 첨부 건축물대장을 기준으로 합니다</a:t>
             </a:r>
             <a:endParaRPr lang="en-US" sz="930" dirty="0"/>
           </a:p>
@@ -7856,7 +7856,7 @@
                 <a:ea typeface="Pretendard" pitchFamily="34" charset="-122"/>
                 <a:cs typeface="Pretendard" pitchFamily="34" charset="-120"/>
               </a:rPr>
-              <a:t>현재 연 순수익률 (Cap Rate)</a:t>
+              <a:t>현재 연 순수익률 (Cap R</a:t>
             </a:r>
             <a:endParaRPr lang="en-US" sz="950" dirty="0"/>
           </a:p>
@@ -7893,11 +7893,11 @@
                 <a:solidFill>
                   <a:srgbClr val="0F172A"/>
                 </a:solidFill>
-                <a:latin typeface="Pretendard" pitchFamily="34" charset="0"/>
-                <a:ea typeface="Pretendard" pitchFamily="34" charset="-122"/>
-                <a:cs typeface="Pretendard" pitchFamily="34" charset="-120"/>
-              </a:rPr>
-              <a:t>2.08% (연간 실질 임대수입 2억 3,352만 원)</a:t>
+                <a:latin typeface="Arial" pitchFamily="34" charset="0"/>
+                <a:ea typeface="Arial" pitchFamily="34" charset="-122"/>
+                <a:cs typeface="Arial" pitchFamily="34" charset="-120"/>
+              </a:rPr>
+              <a:t>2.08%</a:t>
             </a:r>
             <a:endParaRPr lang="en-US" sz="2200" dirty="0"/>
           </a:p>
@@ -8096,11 +8096,11 @@
                 <a:solidFill>
                   <a:srgbClr val="0F172A"/>
                 </a:solidFill>
-                <a:latin typeface="Pretendard" pitchFamily="34" charset="0"/>
-                <a:ea typeface="Pretendard" pitchFamily="34" charset="-122"/>
-                <a:cs typeface="Pretendard" pitchFamily="34" charset="-120"/>
-              </a:rPr>
-              <a:t>갱신요구권(7년 잔여)으로 인해 시세 대신 법정 5% 상한(273만 원) 적용</a:t>
+                <a:latin typeface="Arial" pitchFamily="34" charset="0"/>
+                <a:ea typeface="Arial" pitchFamily="34" charset="-122"/>
+                <a:cs typeface="Arial" pitchFamily="34" charset="-120"/>
+              </a:rPr>
+              <a:t>5%</a:t>
             </a:r>
             <a:endParaRPr lang="en-US" sz="2200" dirty="0"/>
           </a:p>
@@ -8203,11 +8203,11 @@
                 <a:solidFill>
                   <a:srgbClr val="0F172A"/>
                 </a:solidFill>
-                <a:latin typeface="Pretendard" pitchFamily="34" charset="0"/>
-                <a:ea typeface="Pretendard" pitchFamily="34" charset="-122"/>
-                <a:cs typeface="Pretendard" pitchFamily="34" charset="-120"/>
-              </a:rPr>
-              <a:t>2.99% (실투자금 기준 3.09%)</a:t>
+                <a:latin typeface="Arial" pitchFamily="34" charset="0"/>
+                <a:ea typeface="Arial" pitchFamily="34" charset="-122"/>
+                <a:cs typeface="Arial" pitchFamily="34" charset="-120"/>
+              </a:rPr>
+              <a:t>2.99%</a:t>
             </a:r>
             <a:endParaRPr lang="en-US" sz="1800" dirty="0"/>
           </a:p>
@@ -8215,130 +8215,7 @@
       </p:sp>
       <p:sp>
         <p:nvSpPr>
-          <p:cNvPr id="19" name="Shape 17"/>
-          <p:cNvSpPr/>
-          <p:nvPr/>
-        </p:nvSpPr>
-        <p:spPr>
-          <a:xfrm>
-            <a:off x="566928" y="4626864"/>
-            <a:ext cx="11057839" cy="1280160"/>
-          </a:xfrm>
-          <a:prstGeom prst="roundRect">
-            <a:avLst>
-              <a:gd name="adj" fmla="val 4286"/>
-            </a:avLst>
-          </a:prstGeom>
-          <a:solidFill>
-            <a:srgbClr val="DBEAFE"/>
-          </a:solidFill>
-          <a:ln/>
-        </p:spPr>
-      </p:sp>
-      <p:sp>
-        <p:nvSpPr>
-          <p:cNvPr id="20" name="Shape 18"/>
-          <p:cNvSpPr/>
-          <p:nvPr/>
-        </p:nvSpPr>
-        <p:spPr>
-          <a:xfrm>
-            <a:off x="566928" y="4681728"/>
-            <a:ext cx="36576" cy="1170432"/>
-          </a:xfrm>
-          <a:prstGeom prst="rect">
-            <a:avLst/>
-          </a:prstGeom>
-          <a:solidFill>
-            <a:srgbClr val="1D4ED8"/>
-          </a:solidFill>
-          <a:ln/>
-        </p:spPr>
-      </p:sp>
-      <p:sp>
-        <p:nvSpPr>
-          <p:cNvPr id="21" name="Text 19"/>
-          <p:cNvSpPr/>
-          <p:nvPr/>
-        </p:nvSpPr>
-        <p:spPr>
-          <a:xfrm>
-            <a:off x="749808" y="4736592"/>
-            <a:ext cx="10728655" cy="201168"/>
-          </a:xfrm>
-          <a:prstGeom prst="rect">
-            <a:avLst/>
-          </a:prstGeom>
-          <a:noFill/>
-          <a:ln/>
-        </p:spPr>
-        <p:txBody>
-          <a:bodyPr wrap="square" lIns="0" tIns="0" rIns="0" bIns="0" rtlCol="0" anchor="ctr"/>
-          <a:lstStyle/>
-          <a:p>
-            <a:pPr indent="0" marL="0">
-              <a:buNone/>
-            </a:pPr>
-            <a:r>
-              <a:rPr lang="en-US" sz="1050" b="1" dirty="0">
-                <a:solidFill>
-                  <a:srgbClr val="1D4ED8"/>
-                </a:solidFill>
-                <a:latin typeface="Pretendard" pitchFamily="34" charset="0"/>
-                <a:ea typeface="Pretendard" pitchFamily="34" charset="-122"/>
-                <a:cs typeface="Pretendard" pitchFamily="34" charset="-120"/>
-              </a:rPr>
-              <a:t>투자 가치 제안</a:t>
-            </a:r>
-            <a:endParaRPr lang="en-US" sz="1050" dirty="0"/>
-          </a:p>
-        </p:txBody>
-      </p:sp>
-      <p:sp>
-        <p:nvSpPr>
-          <p:cNvPr id="22" name="Text 20"/>
-          <p:cNvSpPr/>
-          <p:nvPr/>
-        </p:nvSpPr>
-        <p:spPr>
-          <a:xfrm>
-            <a:off x="749808" y="4956048"/>
-            <a:ext cx="10728655" cy="877824"/>
-          </a:xfrm>
-          <a:prstGeom prst="rect">
-            <a:avLst/>
-          </a:prstGeom>
-          <a:noFill/>
-          <a:ln/>
-        </p:spPr>
-        <p:txBody>
-          <a:bodyPr wrap="square" lIns="0" tIns="0" rIns="0" bIns="0" rtlCol="0" anchor="t"/>
-          <a:lstStyle/>
-          <a:p>
-            <a:pPr indent="0" marL="0">
-              <a:lnSpc>
-                <a:spcPct val="120000"/>
-              </a:lnSpc>
-              <a:buNone/>
-            </a:pPr>
-            <a:r>
-              <a:rPr lang="en-US" sz="930" dirty="0">
-                <a:solidFill>
-                  <a:srgbClr val="0F172A"/>
-                </a:solidFill>
-                <a:latin typeface="Pretendard" pitchFamily="34" charset="0"/>
-                <a:ea typeface="Pretendard" pitchFamily="34" charset="-122"/>
-                <a:cs typeface="Pretendard" pitchFamily="34" charset="-120"/>
-              </a:rPr>
-              <a:t>본 자산은 우수한 입지 경쟁력과 견고한 펀더멘털을 바탕으로 안정적인 현금흐름 창출과 중장기 자산 가치 상승을 동시에 실현할 수 있는 우량 투자 기회입니다.</a:t>
-            </a:r>
-            <a:endParaRPr lang="en-US" sz="930" dirty="0"/>
-          </a:p>
-        </p:txBody>
-      </p:sp>
-      <p:sp>
-        <p:nvSpPr>
-          <p:cNvPr id="23" name="Text 21"/>
+          <p:cNvPr id="19" name="Text 17"/>
           <p:cNvSpPr/>
           <p:nvPr/>
         </p:nvSpPr>
@@ -8377,7 +8254,7 @@
       </p:sp>
       <p:sp>
         <p:nvSpPr>
-          <p:cNvPr id="24" name="Shape 22"/>
+          <p:cNvPr id="20" name="Shape 18"/>
           <p:cNvSpPr/>
           <p:nvPr/>
         </p:nvSpPr>
@@ -10151,7 +10028,7 @@
                 <a:ea typeface="Pretendard" pitchFamily="34" charset="-122"/>
                 <a:cs typeface="Pretendard" pitchFamily="34" charset="-120"/>
               </a:rPr>
-              <a:t>본 자산은 우수한 권역 입지 경쟁력과 견고한 펀더멘털을 기반으로 중장기 자산 가치 상승 및 안정적인 현금흐름을 동시에 실현할 수 있는 전략적 투자 기회입니다.</a:t>
+              <a:t>본 자산에 대한 상세 분석 및 투자 의사결정은 원본 임대차 계약서 및 공부상 권리관계 실사를 바탕으로 진행됩니다.</a:t>
             </a:r>
             <a:endParaRPr lang="en-US" sz="1100" dirty="0"/>
           </a:p>
@@ -10403,7 +10280,7 @@
         <p:spPr>
           <a:xfrm>
             <a:off x="786384" y="1792224"/>
-            <a:ext cx="384048" cy="384048"/>
+            <a:ext cx="438912" cy="438912"/>
           </a:xfrm>
           <a:prstGeom prst="ellipse">
             <a:avLst/>
@@ -10423,7 +10300,7 @@
         <p:spPr>
           <a:xfrm>
             <a:off x="786384" y="1792224"/>
-            <a:ext cx="384048" cy="384048"/>
+            <a:ext cx="438912" cy="438912"/>
           </a:xfrm>
           <a:prstGeom prst="rect">
             <a:avLst/>
@@ -10439,7 +10316,7 @@
               <a:buNone/>
             </a:pPr>
             <a:r>
-              <a:rPr lang="en-US" sz="1300" b="1" dirty="0">
+              <a:rPr lang="en-US" sz="1400" b="1" dirty="0">
                 <a:solidFill>
                   <a:srgbClr val="FFFFFF"/>
                 </a:solidFill>
@@ -10447,9 +10324,9 @@
                 <a:ea typeface="Arial" pitchFamily="34" charset="-122"/>
                 <a:cs typeface="Arial" pitchFamily="34" charset="-120"/>
               </a:rPr>
-              <a:t>STEP 1</a:t>
-            </a:r>
-            <a:endParaRPr lang="en-US" sz="1300" dirty="0"/>
+              <a:t>01</a:t>
+            </a:r>
+            <a:endParaRPr lang="en-US" sz="1400" dirty="0"/>
           </a:p>
         </p:txBody>
       </p:sp>
@@ -10610,7 +10487,7 @@
         <p:spPr>
           <a:xfrm>
             <a:off x="4594250" y="1792224"/>
-            <a:ext cx="384048" cy="384048"/>
+            <a:ext cx="438912" cy="438912"/>
           </a:xfrm>
           <a:prstGeom prst="ellipse">
             <a:avLst/>
@@ -10630,7 +10507,7 @@
         <p:spPr>
           <a:xfrm>
             <a:off x="4594250" y="1792224"/>
-            <a:ext cx="384048" cy="384048"/>
+            <a:ext cx="438912" cy="438912"/>
           </a:xfrm>
           <a:prstGeom prst="rect">
             <a:avLst/>
@@ -10646,7 +10523,7 @@
               <a:buNone/>
             </a:pPr>
             <a:r>
-              <a:rPr lang="en-US" sz="1300" b="1" dirty="0">
+              <a:rPr lang="en-US" sz="1400" b="1" dirty="0">
                 <a:solidFill>
                   <a:srgbClr val="FFFFFF"/>
                 </a:solidFill>
@@ -10654,9 +10531,9 @@
                 <a:ea typeface="Arial" pitchFamily="34" charset="-122"/>
                 <a:cs typeface="Arial" pitchFamily="34" charset="-120"/>
               </a:rPr>
-              <a:t>STEP 2</a:t>
-            </a:r>
-            <a:endParaRPr lang="en-US" sz="1300" dirty="0"/>
+              <a:t>02</a:t>
+            </a:r>
+            <a:endParaRPr lang="en-US" sz="1400" dirty="0"/>
           </a:p>
         </p:txBody>
       </p:sp>
@@ -10817,7 +10694,7 @@
         <p:spPr>
           <a:xfrm>
             <a:off x="8402117" y="1792224"/>
-            <a:ext cx="384048" cy="384048"/>
+            <a:ext cx="438912" cy="438912"/>
           </a:xfrm>
           <a:prstGeom prst="ellipse">
             <a:avLst/>
@@ -10837,7 +10714,7 @@
         <p:spPr>
           <a:xfrm>
             <a:off x="8402117" y="1792224"/>
-            <a:ext cx="384048" cy="384048"/>
+            <a:ext cx="438912" cy="438912"/>
           </a:xfrm>
           <a:prstGeom prst="rect">
             <a:avLst/>
@@ -10853,7 +10730,7 @@
               <a:buNone/>
             </a:pPr>
             <a:r>
-              <a:rPr lang="en-US" sz="1300" b="1" dirty="0">
+              <a:rPr lang="en-US" sz="1400" b="1" dirty="0">
                 <a:solidFill>
                   <a:srgbClr val="FFFFFF"/>
                 </a:solidFill>
@@ -10861,9 +10738,9 @@
                 <a:ea typeface="Arial" pitchFamily="34" charset="-122"/>
                 <a:cs typeface="Arial" pitchFamily="34" charset="-120"/>
               </a:rPr>
-              <a:t>STEP 3</a:t>
-            </a:r>
-            <a:endParaRPr lang="en-US" sz="1300" dirty="0"/>
+              <a:t>03</a:t>
+            </a:r>
+            <a:endParaRPr lang="en-US" sz="1400" dirty="0"/>
           </a:p>
         </p:txBody>
       </p:sp>

</xml_diff>